<commit_message>
remove html from main folder
</commit_message>
<xml_diff>
--- a/varicat_030823_presentation.pptx
+++ b/varicat_030823_presentation.pptx
@@ -137,7 +137,7 @@
 <file path=ppt/revisionInfo.xml><?xml version="1.0" encoding="utf-8"?>
 <p1510:revInfo xmlns:a="http://schemas.openxmlformats.org/drawingml/2006/main" xmlns:r="http://schemas.openxmlformats.org/officeDocument/2006/relationships" xmlns:p1510="http://schemas.microsoft.com/office/powerpoint/2015/10/main">
   <p1510:revLst>
-    <p1510:client id="{C7797854-3E62-4497-B159-E7F85CB3B86C}" v="375" dt="2023-03-08T15:04:06.001"/>
+    <p1510:client id="{C7797854-3E62-4497-B159-E7F85CB3B86C}" v="377" dt="2023-03-13T17:03:58.636"/>
   </p1510:revLst>
 </p1510:revInfo>
 </file>
@@ -147,7 +147,7 @@
   <pc:docChgLst>
     <pc:chgData name="Hui Xin Ng" userId="8919a21b-636c-4af1-bbae-e8e86829590c" providerId="ADAL" clId="{C7797854-3E62-4497-B159-E7F85CB3B86C}"/>
     <pc:docChg chg="undo custSel addSld delSld modSld sldOrd">
-      <pc:chgData name="Hui Xin Ng" userId="8919a21b-636c-4af1-bbae-e8e86829590c" providerId="ADAL" clId="{C7797854-3E62-4497-B159-E7F85CB3B86C}" dt="2023-03-08T15:06:57.218" v="6566" actId="729"/>
+      <pc:chgData name="Hui Xin Ng" userId="8919a21b-636c-4af1-bbae-e8e86829590c" providerId="ADAL" clId="{C7797854-3E62-4497-B159-E7F85CB3B86C}" dt="2023-03-13T17:07:27.204" v="6570" actId="1076"/>
       <pc:docMkLst>
         <pc:docMk/>
       </pc:docMkLst>
@@ -2448,7 +2448,7 @@
         </pc:picChg>
       </pc:sldChg>
       <pc:sldChg chg="addSp delSp modSp new mod">
-        <pc:chgData name="Hui Xin Ng" userId="8919a21b-636c-4af1-bbae-e8e86829590c" providerId="ADAL" clId="{C7797854-3E62-4497-B159-E7F85CB3B86C}" dt="2023-03-08T14:57:56.897" v="6424" actId="20577"/>
+        <pc:chgData name="Hui Xin Ng" userId="8919a21b-636c-4af1-bbae-e8e86829590c" providerId="ADAL" clId="{C7797854-3E62-4497-B159-E7F85CB3B86C}" dt="2023-03-13T17:03:58.635" v="6568" actId="14100"/>
         <pc:sldMkLst>
           <pc:docMk/>
           <pc:sldMk cId="3104111223" sldId="273"/>
@@ -2502,7 +2502,7 @@
           </ac:spMkLst>
         </pc:spChg>
         <pc:picChg chg="add mod">
-          <ac:chgData name="Hui Xin Ng" userId="8919a21b-636c-4af1-bbae-e8e86829590c" providerId="ADAL" clId="{C7797854-3E62-4497-B159-E7F85CB3B86C}" dt="2023-03-08T14:56:26.201" v="6302" actId="1076"/>
+          <ac:chgData name="Hui Xin Ng" userId="8919a21b-636c-4af1-bbae-e8e86829590c" providerId="ADAL" clId="{C7797854-3E62-4497-B159-E7F85CB3B86C}" dt="2023-03-13T17:03:58.635" v="6568" actId="14100"/>
           <ac:picMkLst>
             <pc:docMk/>
             <pc:sldMk cId="3104111223" sldId="273"/>
@@ -2527,7 +2527,7 @@
         </pc:picChg>
       </pc:sldChg>
       <pc:sldChg chg="addSp delSp modSp add mod modShow modNotesTx">
-        <pc:chgData name="Hui Xin Ng" userId="8919a21b-636c-4af1-bbae-e8e86829590c" providerId="ADAL" clId="{C7797854-3E62-4497-B159-E7F85CB3B86C}" dt="2023-03-08T15:06:57.218" v="6566" actId="729"/>
+        <pc:chgData name="Hui Xin Ng" userId="8919a21b-636c-4af1-bbae-e8e86829590c" providerId="ADAL" clId="{C7797854-3E62-4497-B159-E7F85CB3B86C}" dt="2023-03-13T17:07:27.204" v="6570" actId="1076"/>
         <pc:sldMkLst>
           <pc:docMk/>
           <pc:sldMk cId="879984273" sldId="274"/>
@@ -2549,7 +2549,7 @@
           </ac:spMkLst>
         </pc:spChg>
         <pc:spChg chg="add mod">
-          <ac:chgData name="Hui Xin Ng" userId="8919a21b-636c-4af1-bbae-e8e86829590c" providerId="ADAL" clId="{C7797854-3E62-4497-B159-E7F85CB3B86C}" dt="2023-03-08T15:06:04.006" v="6565" actId="1076"/>
+          <ac:chgData name="Hui Xin Ng" userId="8919a21b-636c-4af1-bbae-e8e86829590c" providerId="ADAL" clId="{C7797854-3E62-4497-B159-E7F85CB3B86C}" dt="2023-03-13T17:07:27.204" v="6570" actId="1076"/>
           <ac:spMkLst>
             <pc:docMk/>
             <pc:sldMk cId="879984273" sldId="274"/>
@@ -2692,7 +2692,7 @@
           <a:p>
             <a:fld id="{6BD846F1-EA5A-47E9-B343-9A0BCCB09028}" type="datetimeFigureOut">
               <a:rPr lang="en-US" smtClean="0"/>
-              <a:t>3/8/2023</a:t>
+              <a:t>3/13/2023</a:t>
             </a:fld>
             <a:endParaRPr lang="en-US"/>
           </a:p>
@@ -4726,7 +4726,7 @@
           <a:p>
             <a:fld id="{6C6B1B08-17AE-44D7-8669-EBB3539C7368}" type="datetimeFigureOut">
               <a:rPr lang="en-US" smtClean="0"/>
-              <a:t>3/8/2023</a:t>
+              <a:t>3/13/2023</a:t>
             </a:fld>
             <a:endParaRPr lang="en-US"/>
           </a:p>
@@ -4924,7 +4924,7 @@
           <a:p>
             <a:fld id="{6C6B1B08-17AE-44D7-8669-EBB3539C7368}" type="datetimeFigureOut">
               <a:rPr lang="en-US" smtClean="0"/>
-              <a:t>3/8/2023</a:t>
+              <a:t>3/13/2023</a:t>
             </a:fld>
             <a:endParaRPr lang="en-US"/>
           </a:p>
@@ -5132,7 +5132,7 @@
           <a:p>
             <a:fld id="{6C6B1B08-17AE-44D7-8669-EBB3539C7368}" type="datetimeFigureOut">
               <a:rPr lang="en-US" smtClean="0"/>
-              <a:t>3/8/2023</a:t>
+              <a:t>3/13/2023</a:t>
             </a:fld>
             <a:endParaRPr lang="en-US"/>
           </a:p>
@@ -5330,7 +5330,7 @@
           <a:p>
             <a:fld id="{6C6B1B08-17AE-44D7-8669-EBB3539C7368}" type="datetimeFigureOut">
               <a:rPr lang="en-US" smtClean="0"/>
-              <a:t>3/8/2023</a:t>
+              <a:t>3/13/2023</a:t>
             </a:fld>
             <a:endParaRPr lang="en-US"/>
           </a:p>
@@ -5605,7 +5605,7 @@
           <a:p>
             <a:fld id="{6C6B1B08-17AE-44D7-8669-EBB3539C7368}" type="datetimeFigureOut">
               <a:rPr lang="en-US" smtClean="0"/>
-              <a:t>3/8/2023</a:t>
+              <a:t>3/13/2023</a:t>
             </a:fld>
             <a:endParaRPr lang="en-US"/>
           </a:p>
@@ -5870,7 +5870,7 @@
           <a:p>
             <a:fld id="{6C6B1B08-17AE-44D7-8669-EBB3539C7368}" type="datetimeFigureOut">
               <a:rPr lang="en-US" smtClean="0"/>
-              <a:t>3/8/2023</a:t>
+              <a:t>3/13/2023</a:t>
             </a:fld>
             <a:endParaRPr lang="en-US"/>
           </a:p>
@@ -6282,7 +6282,7 @@
           <a:p>
             <a:fld id="{6C6B1B08-17AE-44D7-8669-EBB3539C7368}" type="datetimeFigureOut">
               <a:rPr lang="en-US" smtClean="0"/>
-              <a:t>3/8/2023</a:t>
+              <a:t>3/13/2023</a:t>
             </a:fld>
             <a:endParaRPr lang="en-US"/>
           </a:p>
@@ -6423,7 +6423,7 @@
           <a:p>
             <a:fld id="{6C6B1B08-17AE-44D7-8669-EBB3539C7368}" type="datetimeFigureOut">
               <a:rPr lang="en-US" smtClean="0"/>
-              <a:t>3/8/2023</a:t>
+              <a:t>3/13/2023</a:t>
             </a:fld>
             <a:endParaRPr lang="en-US"/>
           </a:p>
@@ -6536,7 +6536,7 @@
           <a:p>
             <a:fld id="{6C6B1B08-17AE-44D7-8669-EBB3539C7368}" type="datetimeFigureOut">
               <a:rPr lang="en-US" smtClean="0"/>
-              <a:t>3/8/2023</a:t>
+              <a:t>3/13/2023</a:t>
             </a:fld>
             <a:endParaRPr lang="en-US"/>
           </a:p>
@@ -6847,7 +6847,7 @@
           <a:p>
             <a:fld id="{6C6B1B08-17AE-44D7-8669-EBB3539C7368}" type="datetimeFigureOut">
               <a:rPr lang="en-US" smtClean="0"/>
-              <a:t>3/8/2023</a:t>
+              <a:t>3/13/2023</a:t>
             </a:fld>
             <a:endParaRPr lang="en-US"/>
           </a:p>
@@ -7135,7 +7135,7 @@
           <a:p>
             <a:fld id="{6C6B1B08-17AE-44D7-8669-EBB3539C7368}" type="datetimeFigureOut">
               <a:rPr lang="en-US" smtClean="0"/>
-              <a:t>3/8/2023</a:t>
+              <a:t>3/13/2023</a:t>
             </a:fld>
             <a:endParaRPr lang="en-US"/>
           </a:p>
@@ -7376,7 +7376,7 @@
           <a:p>
             <a:fld id="{6C6B1B08-17AE-44D7-8669-EBB3539C7368}" type="datetimeFigureOut">
               <a:rPr lang="en-US" smtClean="0"/>
-              <a:t>3/8/2023</a:t>
+              <a:t>3/13/2023</a:t>
             </a:fld>
             <a:endParaRPr lang="en-US"/>
           </a:p>
@@ -13966,7 +13966,7 @@
         <p:spPr bwMode="auto">
           <a:xfrm>
             <a:off x="171290" y="1819857"/>
-            <a:ext cx="5660550" cy="3903394"/>
+            <a:ext cx="5395852" cy="3720864"/>
           </a:xfrm>
           <a:prstGeom prst="rect">
             <a:avLst/>
@@ -14350,7 +14350,7 @@
         </p:nvSpPr>
         <p:spPr>
           <a:xfrm>
-            <a:off x="368135" y="1104406"/>
+            <a:off x="463162" y="1104406"/>
             <a:ext cx="4500748" cy="923330"/>
           </a:xfrm>
           <a:prstGeom prst="rect">

</xml_diff>